<commit_message>
Fichiers par compte régénérés (catégories d'août)
Co-Authored-By: Claude Opus 5.5 <noreply@anthropic.com>
Claude-Session: https://claude.ai/code/session_01BmxtdWjbeRUyPx9e1qVLbT
</commit_message>
<xml_diff>
--- a/rapports/septembre/1001_Pneus_sept2026.pptx
+++ b/rapports/septembre/1001_Pneus_sept2026.pptx
@@ -6217,7 +6217,7 @@
         <p:spPr>
           <a:xfrm>
             <a:off x="8296656" y="4389120"/>
-            <a:ext cx="2072640" cy="152400"/>
+            <a:ext cx="2225040" cy="152400"/>
           </a:xfrm>
           <a:prstGeom prst="rect">
             <a:avLst/>
@@ -6238,7 +6238,7 @@
                 </a:solidFill>
                 <a:latin typeface="Arial"/>
               </a:rPr>
-              <a:t>Pneus auto et dimensions</a:t>
+              <a:t>Saison et changement de pneus</a:t>
             </a:r>
           </a:p>
         </p:txBody>
@@ -6296,7 +6296,7 @@
         <p:spPr>
           <a:xfrm>
             <a:off x="8296656" y="4657344"/>
-            <a:ext cx="2072640" cy="152400"/>
+            <a:ext cx="2225040" cy="152400"/>
           </a:xfrm>
           <a:prstGeom prst="rect">
             <a:avLst/>
@@ -6317,7 +6317,7 @@
                 </a:solidFill>
                 <a:latin typeface="Arial"/>
               </a:rPr>
-              <a:t>Jantes et roues · 15 %</a:t>
+              <a:t>Sécurité et tenue de route · 23 %</a:t>
             </a:r>
           </a:p>
         </p:txBody>
@@ -6375,7 +6375,7 @@
         <p:spPr>
           <a:xfrm>
             <a:off x="8296656" y="4925568"/>
-            <a:ext cx="2072640" cy="152400"/>
+            <a:ext cx="2225040" cy="152400"/>
           </a:xfrm>
           <a:prstGeom prst="rect">
             <a:avLst/>
@@ -6390,13 +6390,13 @@
           <a:p>
             <a:pPr algn="l"/>
             <a:r>
-              <a:rPr sz="1000" b="0" i="0">
+              <a:rPr sz="800" b="0" i="0">
                 <a:solidFill>
                   <a:srgbClr val="111111"/>
                 </a:solidFill>
                 <a:latin typeface="Arial"/>
               </a:rPr>
-              <a:t>Pneus hiver et neige · 9 %</a:t>
+              <a:t>Usage professionnel et utilitaire · 12 %</a:t>
             </a:r>
           </a:p>
         </p:txBody>
@@ -6454,7 +6454,7 @@
         <p:spPr>
           <a:xfrm>
             <a:off x="8296656" y="5193792"/>
-            <a:ext cx="2072640" cy="152400"/>
+            <a:ext cx="2225040" cy="152400"/>
           </a:xfrm>
           <a:prstGeom prst="rect">
             <a:avLst/>
@@ -6469,13 +6469,13 @@
           <a:p>
             <a:pPr algn="l"/>
             <a:r>
-              <a:rPr sz="1000" b="0" i="0">
+              <a:rPr sz="800" b="0" i="0">
                 <a:solidFill>
                   <a:srgbClr val="111111"/>
                 </a:solidFill>
                 <a:latin typeface="Arial"/>
               </a:rPr>
-              <a:t>Crevaison et dépannage · 7 %</a:t>
+              <a:t>Économie, autonomie et durabilité · 10 %</a:t>
             </a:r>
           </a:p>
         </p:txBody>
@@ -6488,166 +6488,8 @@
         </p:nvSpPr>
         <p:spPr>
           <a:xfrm>
-            <a:off x="8077200" y="5480304"/>
-            <a:ext cx="121920" cy="121920"/>
-          </a:xfrm>
-          <a:prstGeom prst="rect">
-            <a:avLst/>
-          </a:prstGeom>
-          <a:solidFill>
-            <a:srgbClr val="3E5A78"/>
-          </a:solidFill>
-          <a:ln>
-            <a:noFill/>
-          </a:ln>
-          <a:effectLst/>
-        </p:spPr>
-        <p:style>
-          <a:lnRef idx="1">
-            <a:schemeClr val="accent1"/>
-          </a:lnRef>
-          <a:fillRef idx="3">
-            <a:schemeClr val="accent1"/>
-          </a:fillRef>
-          <a:effectRef idx="2">
-            <a:schemeClr val="accent1"/>
-          </a:effectRef>
-          <a:fontRef idx="minor">
-            <a:schemeClr val="lt1"/>
-          </a:fontRef>
-        </p:style>
-        <p:txBody>
-          <a:bodyPr rtlCol="0" anchor="ctr"/>
-          <a:lstStyle/>
-          <a:p>
-            <a:pPr algn="ctr"/>
-          </a:p>
-        </p:txBody>
-      </p:sp>
-      <p:sp>
-        <p:nvSpPr>
-          <p:cNvPr id="89" name="TextBox 88"/>
-          <p:cNvSpPr txBox="1"/>
-          <p:nvPr/>
-        </p:nvSpPr>
-        <p:spPr>
-          <a:xfrm>
-            <a:off x="8296656" y="5462016"/>
-            <a:ext cx="2072640" cy="152400"/>
-          </a:xfrm>
-          <a:prstGeom prst="rect">
-            <a:avLst/>
-          </a:prstGeom>
-          <a:noFill/>
-        </p:spPr>
-        <p:txBody>
-          <a:bodyPr wrap="square" anchor="t" lIns="0" rIns="0" tIns="0" bIns="0">
-            <a:spAutoFit/>
-          </a:bodyPr>
-          <a:lstStyle/>
-          <a:p>
-            <a:pPr algn="l"/>
-            <a:r>
-              <a:rPr sz="1000" b="0" i="0">
-                <a:solidFill>
-                  <a:srgbClr val="111111"/>
-                </a:solidFill>
-                <a:latin typeface="Arial"/>
-              </a:rPr>
-              <a:t>Pneus été et toutes saisons · 2 %</a:t>
-            </a:r>
-          </a:p>
-        </p:txBody>
-      </p:sp>
-      <p:sp>
-        <p:nvSpPr>
-          <p:cNvPr id="90" name="Rectangle 89"/>
-          <p:cNvSpPr/>
-          <p:nvPr/>
-        </p:nvSpPr>
-        <p:spPr>
-          <a:xfrm>
-            <a:off x="8077200" y="5748528"/>
-            <a:ext cx="121920" cy="121920"/>
-          </a:xfrm>
-          <a:prstGeom prst="rect">
-            <a:avLst/>
-          </a:prstGeom>
-          <a:solidFill>
-            <a:srgbClr val="A09278"/>
-          </a:solidFill>
-          <a:ln>
-            <a:noFill/>
-          </a:ln>
-          <a:effectLst/>
-        </p:spPr>
-        <p:style>
-          <a:lnRef idx="1">
-            <a:schemeClr val="accent1"/>
-          </a:lnRef>
-          <a:fillRef idx="3">
-            <a:schemeClr val="accent1"/>
-          </a:fillRef>
-          <a:effectRef idx="2">
-            <a:schemeClr val="accent1"/>
-          </a:effectRef>
-          <a:fontRef idx="minor">
-            <a:schemeClr val="lt1"/>
-          </a:fontRef>
-        </p:style>
-        <p:txBody>
-          <a:bodyPr rtlCol="0" anchor="ctr"/>
-          <a:lstStyle/>
-          <a:p>
-            <a:pPr algn="ctr"/>
-          </a:p>
-        </p:txBody>
-      </p:sp>
-      <p:sp>
-        <p:nvSpPr>
-          <p:cNvPr id="91" name="TextBox 90"/>
-          <p:cNvSpPr txBox="1"/>
-          <p:nvPr/>
-        </p:nvSpPr>
-        <p:spPr>
-          <a:xfrm>
-            <a:off x="8296656" y="5730240"/>
-            <a:ext cx="2072640" cy="152400"/>
-          </a:xfrm>
-          <a:prstGeom prst="rect">
-            <a:avLst/>
-          </a:prstGeom>
-          <a:noFill/>
-        </p:spPr>
-        <p:txBody>
-          <a:bodyPr wrap="square" anchor="t" lIns="0" rIns="0" tIns="0" bIns="0">
-            <a:spAutoFit/>
-          </a:bodyPr>
-          <a:lstStyle/>
-          <a:p>
-            <a:pPr algn="l"/>
-            <a:r>
-              <a:rPr sz="1000" b="0" i="0">
-                <a:solidFill>
-                  <a:srgbClr val="111111"/>
-                </a:solidFill>
-                <a:latin typeface="Arial"/>
-              </a:rPr>
-              <a:t>Pneus connectés · 1 %</a:t>
-            </a:r>
-          </a:p>
-        </p:txBody>
-      </p:sp>
-      <p:sp>
-        <p:nvSpPr>
-          <p:cNvPr id="92" name="Rectangle 91"/>
-          <p:cNvSpPr/>
-          <p:nvPr/>
-        </p:nvSpPr>
-        <p:spPr>
-          <a:xfrm>
             <a:off x="10564368" y="4450080"/>
-            <a:ext cx="475488" cy="885139"/>
+            <a:ext cx="475488" cy="737616"/>
           </a:xfrm>
           <a:prstGeom prst="rect">
             <a:avLst/>
@@ -6684,14 +6526,14 @@
       </p:sp>
       <p:sp>
         <p:nvSpPr>
-          <p:cNvPr id="93" name="TextBox 92"/>
+          <p:cNvPr id="89" name="TextBox 88"/>
           <p:cNvSpPr txBox="1"/>
           <p:nvPr/>
         </p:nvSpPr>
         <p:spPr>
           <a:xfrm>
             <a:off x="10564368" y="4450080"/>
-            <a:ext cx="475488" cy="885139"/>
+            <a:ext cx="475488" cy="737616"/>
           </a:xfrm>
           <a:prstGeom prst="rect">
             <a:avLst/>
@@ -6712,21 +6554,21 @@
                 </a:solidFill>
                 <a:latin typeface="Arial"/>
               </a:rPr>
-              <a:t>66 %</a:t>
-            </a:r>
-          </a:p>
-        </p:txBody>
-      </p:sp>
-      <p:sp>
-        <p:nvSpPr>
-          <p:cNvPr id="94" name="Rectangle 93"/>
+              <a:t>55 %</a:t>
+            </a:r>
+          </a:p>
+        </p:txBody>
+      </p:sp>
+      <p:sp>
+        <p:nvSpPr>
+          <p:cNvPr id="90" name="Rectangle 89"/>
           <p:cNvSpPr/>
           <p:nvPr/>
         </p:nvSpPr>
         <p:spPr>
           <a:xfrm>
-            <a:off x="10564368" y="5335219"/>
-            <a:ext cx="475488" cy="201168"/>
+            <a:off x="10564368" y="5187696"/>
+            <a:ext cx="475488" cy="308457"/>
           </a:xfrm>
           <a:prstGeom prst="rect">
             <a:avLst/>
@@ -6763,14 +6605,14 @@
       </p:sp>
       <p:sp>
         <p:nvSpPr>
-          <p:cNvPr id="95" name="Rectangle 94"/>
+          <p:cNvPr id="91" name="Rectangle 90"/>
           <p:cNvSpPr/>
           <p:nvPr/>
         </p:nvSpPr>
         <p:spPr>
           <a:xfrm>
-            <a:off x="10564368" y="5536387"/>
-            <a:ext cx="475488" cy="120700"/>
+            <a:off x="10564368" y="5496153"/>
+            <a:ext cx="475488" cy="160934"/>
           </a:xfrm>
           <a:prstGeom prst="rect">
             <a:avLst/>
@@ -6807,108 +6649,20 @@
       </p:sp>
       <p:sp>
         <p:nvSpPr>
-          <p:cNvPr id="96" name="Rectangle 95"/>
+          <p:cNvPr id="92" name="Rectangle 91"/>
           <p:cNvSpPr/>
           <p:nvPr/>
         </p:nvSpPr>
         <p:spPr>
           <a:xfrm>
             <a:off x="10564368" y="5657088"/>
-            <a:ext cx="475488" cy="93878"/>
+            <a:ext cx="475488" cy="134112"/>
           </a:xfrm>
           <a:prstGeom prst="rect">
             <a:avLst/>
           </a:prstGeom>
           <a:solidFill>
             <a:srgbClr val="EE6A2C"/>
-          </a:solidFill>
-          <a:ln>
-            <a:noFill/>
-          </a:ln>
-          <a:effectLst/>
-        </p:spPr>
-        <p:style>
-          <a:lnRef idx="1">
-            <a:schemeClr val="accent1"/>
-          </a:lnRef>
-          <a:fillRef idx="3">
-            <a:schemeClr val="accent1"/>
-          </a:fillRef>
-          <a:effectRef idx="2">
-            <a:schemeClr val="accent1"/>
-          </a:effectRef>
-          <a:fontRef idx="minor">
-            <a:schemeClr val="lt1"/>
-          </a:fontRef>
-        </p:style>
-        <p:txBody>
-          <a:bodyPr rtlCol="0" anchor="ctr"/>
-          <a:lstStyle/>
-          <a:p>
-            <a:pPr algn="ctr"/>
-          </a:p>
-        </p:txBody>
-      </p:sp>
-      <p:sp>
-        <p:nvSpPr>
-          <p:cNvPr id="97" name="Rectangle 96"/>
-          <p:cNvSpPr/>
-          <p:nvPr/>
-        </p:nvSpPr>
-        <p:spPr>
-          <a:xfrm>
-            <a:off x="10564368" y="5750966"/>
-            <a:ext cx="475488" cy="26822"/>
-          </a:xfrm>
-          <a:prstGeom prst="rect">
-            <a:avLst/>
-          </a:prstGeom>
-          <a:solidFill>
-            <a:srgbClr val="3E5A78"/>
-          </a:solidFill>
-          <a:ln>
-            <a:noFill/>
-          </a:ln>
-          <a:effectLst/>
-        </p:spPr>
-        <p:style>
-          <a:lnRef idx="1">
-            <a:schemeClr val="accent1"/>
-          </a:lnRef>
-          <a:fillRef idx="3">
-            <a:schemeClr val="accent1"/>
-          </a:fillRef>
-          <a:effectRef idx="2">
-            <a:schemeClr val="accent1"/>
-          </a:effectRef>
-          <a:fontRef idx="minor">
-            <a:schemeClr val="lt1"/>
-          </a:fontRef>
-        </p:style>
-        <p:txBody>
-          <a:bodyPr rtlCol="0" anchor="ctr"/>
-          <a:lstStyle/>
-          <a:p>
-            <a:pPr algn="ctr"/>
-          </a:p>
-        </p:txBody>
-      </p:sp>
-      <p:sp>
-        <p:nvSpPr>
-          <p:cNvPr id="98" name="Rectangle 97"/>
-          <p:cNvSpPr/>
-          <p:nvPr/>
-        </p:nvSpPr>
-        <p:spPr>
-          <a:xfrm>
-            <a:off x="10564368" y="5777788"/>
-            <a:ext cx="475488" cy="13411"/>
-          </a:xfrm>
-          <a:prstGeom prst="rect">
-            <a:avLst/>
-          </a:prstGeom>
-          <a:solidFill>
-            <a:srgbClr val="A09278"/>
           </a:solidFill>
           <a:ln>
             <a:noFill/>

</xml_diff>